<commit_message>
Add local dev workflow: presentation build script + README guide
- scripts/build_presentation.js (portable path, was previously only on the
  build machine) — regenerate the PPTX deck locally with 'node scripts/build_presentation.js'
- package.json for the pptxgenjs dependency
- README section 12: full local setup (venv, data prep, model training,
  running the dashboard) and instructions for modifying both the dashboard
  and the presentation locally
</commit_message>
<xml_diff>
--- a/documents/Credit_Risk_Platform_Presentation.pptx
+++ b/documents/Credit_Risk_Platform_Presentation.pptx
@@ -2192,7 +2192,7 @@
       </p:sp>
       <p:pic>
         <p:nvPicPr>
-          <p:cNvPr id="4" name="Image 0" descr="/home/claude/credit_risk_platform/documents/screenshots/01_overview.png">    </p:cNvPr>
+          <p:cNvPr id="4" name="Image 0" descr="/home/claude/credit_risk_platform/scripts/../documents/screenshots/01_overview.png">    </p:cNvPr>
           <p:cNvPicPr>
             <a:picLocks noChangeAspect="1"/>
           </p:cNvPicPr>
@@ -2216,7 +2216,7 @@
       </p:pic>
       <p:pic>
         <p:nvPicPr>
-          <p:cNvPr id="5" name="Image 1" descr="/home/claude/credit_risk_platform/documents/screenshots/03b_risk_prediction_result.png">    </p:cNvPr>
+          <p:cNvPr id="5" name="Image 1" descr="/home/claude/credit_risk_platform/scripts/../documents/screenshots/03b_risk_prediction_result.png">    </p:cNvPr>
           <p:cNvPicPr>
             <a:picLocks noChangeAspect="1"/>
           </p:cNvPicPr>
@@ -4439,7 +4439,7 @@
       </p:sp>
       <p:pic>
         <p:nvPicPr>
-          <p:cNvPr id="4" name="Image 0" descr="/home/claude/credit_risk_platform/documents/architecture_diagram.png">    </p:cNvPr>
+          <p:cNvPr id="4" name="Image 0" descr="/home/claude/credit_risk_platform/scripts/../documents/architecture_diagram.png">    </p:cNvPr>
           <p:cNvPicPr>
             <a:picLocks noChangeAspect="1"/>
           </p:cNvPicPr>
@@ -5415,7 +5415,7 @@
       </p:sp>
       <p:pic>
         <p:nvPicPr>
-          <p:cNvPr id="4" name="Image 0" descr="/home/claude/credit_risk_platform/notebooks/eda_charts/01_target_distribution.png">    </p:cNvPr>
+          <p:cNvPr id="4" name="Image 0" descr="/home/claude/credit_risk_platform/scripts/../notebooks/eda_charts/01_target_distribution.png">    </p:cNvPr>
           <p:cNvPicPr>
             <a:picLocks noChangeAspect="1"/>
           </p:cNvPicPr>
@@ -5439,7 +5439,7 @@
       </p:pic>
       <p:pic>
         <p:nvPicPr>
-          <p:cNvPr id="5" name="Image 1" descr="/home/claude/credit_risk_platform/notebooks/eda_charts/04_default_by_bureau_overdue.png">    </p:cNvPr>
+          <p:cNvPr id="5" name="Image 1" descr="/home/claude/credit_risk_platform/scripts/../notebooks/eda_charts/04_default_by_bureau_overdue.png">    </p:cNvPr>
           <p:cNvPicPr>
             <a:picLocks noChangeAspect="1"/>
           </p:cNvPicPr>
@@ -6817,7 +6817,7 @@
       </p:sp>
       <p:pic>
         <p:nvPicPr>
-          <p:cNvPr id="19" name="Image 0" descr="/home/claude/credit_risk_platform/documents/eval_charts/feature_importance.png">    </p:cNvPr>
+          <p:cNvPr id="19" name="Image 0" descr="/home/claude/credit_risk_platform/scripts/../documents/eval_charts/feature_importance.png">    </p:cNvPr>
           <p:cNvPicPr>
             <a:picLocks noChangeAspect="1"/>
           </p:cNvPicPr>
@@ -6990,7 +6990,7 @@
       </p:sp>
       <p:pic>
         <p:nvPicPr>
-          <p:cNvPr id="4" name="Image 0" descr="/home/claude/credit_risk_platform/documents/screenshots/04_explainability.png">    </p:cNvPr>
+          <p:cNvPr id="4" name="Image 0" descr="/home/claude/credit_risk_platform/scripts/../documents/screenshots/04_explainability.png">    </p:cNvPr>
           <p:cNvPicPr>
             <a:picLocks noChangeAspect="1"/>
           </p:cNvPicPr>
@@ -7269,7 +7269,7 @@
       </p:sp>
       <p:pic>
         <p:nvPicPr>
-          <p:cNvPr id="4" name="Image 0" descr="/home/claude/credit_risk_platform/documents/screenshots/05_business_rules.png">    </p:cNvPr>
+          <p:cNvPr id="4" name="Image 0" descr="/home/claude/credit_risk_platform/scripts/../documents/screenshots/05_business_rules.png">    </p:cNvPr>
           <p:cNvPicPr>
             <a:picLocks noChangeAspect="1"/>
           </p:cNvPicPr>
@@ -7548,7 +7548,7 @@
       </p:sp>
       <p:pic>
         <p:nvPicPr>
-          <p:cNvPr id="4" name="Image 0" descr="/home/claude/credit_risk_platform/documents/screenshots/06_talk_to_data.png">    </p:cNvPr>
+          <p:cNvPr id="4" name="Image 0" descr="/home/claude/credit_risk_platform/scripts/../documents/screenshots/06_talk_to_data.png">    </p:cNvPr>
           <p:cNvPicPr>
             <a:picLocks noChangeAspect="1"/>
           </p:cNvPicPr>

</xml_diff>

<commit_message>
Update README and presentation with real 7-table results
- README: ROC-AUC 0.7804 (was 0.7782), PR-AUC 0.2765, recall/precision updated,
  165 features across 6 tables, new cc_max_utilization business rule example,
  corrected an overclaim about credit_card_balance ranking in top-20 feature
  importance (it doesn't, by gain — but it IS a genuine business rule, which
  is itself a useful observation about model importance vs. rule-based signal)
- Presentation: slide 4 now shows all 5 auxiliary tables, slide 6 metrics
  updated, slide 9 chatbot query count corrected to 7, slide 12 limitations
  updated to remove the now-resolved bureau_balance/credit_card_balance item
</commit_message>
<xml_diff>
--- a/documents/Credit_Risk_Platform_Presentation.pptx
+++ b/documents/Credit_Risk_Platform_Presentation.pptx
@@ -3190,7 +3190,7 @@
                 <a:ea typeface="Calibri" pitchFamily="34" charset="-122"/>
                 <a:cs typeface="Calibri" pitchFamily="34" charset="-120"/>
               </a:rPr>
-              <a:t>Two Kaggle tables not yet joined</a:t>
+              <a:t>installments_payments.csv not joined</a:t>
             </a:r>
             <a:endParaRPr lang="en-US" sz="1400" dirty="0"/>
           </a:p>
@@ -3229,7 +3229,7 @@
                 <a:ea typeface="Calibri" pitchFamily="34" charset="-122"/>
                 <a:cs typeface="Calibri" pitchFamily="34" charset="-120"/>
               </a:rPr>
-              <a:t>bureau_balance.csv and credit_card_balance.csv would add further repayment signal on top of what's already used</a:t>
+              <a:t>Repayment-timing signal is already substantially covered by POS_CASH_balance and credit_card_balance's own DPD tracking</a:t>
             </a:r>
             <a:endParaRPr lang="en-US" sz="1200" dirty="0"/>
           </a:p>
@@ -3439,7 +3439,7 @@
                 <a:ea typeface="Calibri" pitchFamily="34" charset="-122"/>
                 <a:cs typeface="Calibri" pitchFamily="34" charset="-120"/>
               </a:rPr>
-              <a:t>Remaining ~140 features filled from population medians/modes — a deliberate UX tradeoff for a demo interface</a:t>
+              <a:t>Remaining ~153 features filled from population medians/modes — a deliberate UX tradeoff for a demo interface</a:t>
             </a:r>
             <a:endParaRPr lang="en-US" sz="1200" dirty="0"/>
           </a:p>
@@ -4643,7 +4643,7 @@
                 <a:ea typeface="Calibri" pitchFamily="34" charset="-122"/>
                 <a:cs typeface="Calibri" pitchFamily="34" charset="-120"/>
               </a:rPr>
-              <a:t>Most submissions on this dataset use application_train.csv alone. This platform joins three additional tables — aggregated in SQL for speed on 10M+ row tables — to capture signal a single-table model would miss.</a:t>
+              <a:t>Most submissions on this dataset use application_train.csv alone. This platform joins five additional tables — aggregated in SQL for speed on tables up to 27M rows — to capture signal a single-table model would miss.</a:t>
             </a:r>
             <a:endParaRPr lang="en-US" sz="1350" dirty="0"/>
           </a:p>
@@ -4657,12 +4657,12 @@
         </p:nvSpPr>
         <p:spPr>
           <a:xfrm>
-            <a:off x="548640" y="2331720"/>
-            <a:ext cx="2697480" cy="3291840"/>
+            <a:off x="457200" y="2331720"/>
+            <a:ext cx="2212848" cy="3291840"/>
           </a:xfrm>
           <a:prstGeom prst="roundRect">
             <a:avLst>
-              <a:gd name="adj" fmla="val 2712"/>
+              <a:gd name="adj" fmla="val 3306"/>
             </a:avLst>
           </a:prstGeom>
           <a:solidFill>
@@ -4684,8 +4684,8 @@
         </p:nvSpPr>
         <p:spPr>
           <a:xfrm>
-            <a:off x="731520" y="2560320"/>
-            <a:ext cx="2331720" cy="548640"/>
+            <a:off x="594360" y="2514600"/>
+            <a:ext cx="1938528" cy="685800"/>
           </a:xfrm>
           <a:prstGeom prst="rect">
             <a:avLst/>
@@ -4701,7 +4701,7 @@
               <a:buNone/>
             </a:pPr>
             <a:r>
-              <a:rPr lang="en-US" sz="1500" b="1" dirty="0">
+              <a:rPr lang="en-US" sz="1300" b="1" dirty="0">
                 <a:solidFill>
                   <a:srgbClr val="E8EDF3"/>
                 </a:solidFill>
@@ -4711,7 +4711,7 @@
               </a:rPr>
               <a:t>applications</a:t>
             </a:r>
-            <a:endParaRPr lang="en-US" sz="1500" dirty="0"/>
+            <a:endParaRPr lang="en-US" sz="1300" dirty="0"/>
           </a:p>
         </p:txBody>
       </p:sp>
@@ -4723,8 +4723,8 @@
         </p:nvSpPr>
         <p:spPr>
           <a:xfrm>
-            <a:off x="731520" y="3063240"/>
-            <a:ext cx="2331720" cy="365760"/>
+            <a:off x="594360" y="3154680"/>
+            <a:ext cx="1938528" cy="365760"/>
           </a:xfrm>
           <a:prstGeom prst="rect">
             <a:avLst/>
@@ -4740,7 +4740,7 @@
               <a:buNone/>
             </a:pPr>
             <a:r>
-              <a:rPr lang="en-US" sz="1200" dirty="0">
+              <a:rPr lang="en-US" sz="1050" dirty="0">
                 <a:solidFill>
                   <a:srgbClr val="3FA796"/>
                 </a:solidFill>
@@ -4750,7 +4750,7 @@
               </a:rPr>
               <a:t>307,511 rows</a:t>
             </a:r>
-            <a:endParaRPr lang="en-US" sz="1200" dirty="0"/>
+            <a:endParaRPr lang="en-US" sz="1050" dirty="0"/>
           </a:p>
         </p:txBody>
       </p:sp>
@@ -4762,8 +4762,8 @@
         </p:nvSpPr>
         <p:spPr>
           <a:xfrm>
-            <a:off x="731520" y="3520440"/>
-            <a:ext cx="2331720" cy="1920240"/>
+            <a:off x="594360" y="3566160"/>
+            <a:ext cx="1938528" cy="1920240"/>
           </a:xfrm>
           <a:prstGeom prst="rect">
             <a:avLst/>
@@ -4779,7 +4779,7 @@
               <a:buNone/>
             </a:pPr>
             <a:r>
-              <a:rPr lang="en-US" sz="1150" dirty="0">
+              <a:rPr lang="en-US" sz="1050" dirty="0">
                 <a:solidFill>
                   <a:srgbClr val="8A97AB"/>
                 </a:solidFill>
@@ -4789,7 +4789,7 @@
               </a:rPr>
               <a:t>Core applicant demographics &amp; loan terms</a:t>
             </a:r>
-            <a:endParaRPr lang="en-US" sz="1150" dirty="0"/>
+            <a:endParaRPr lang="en-US" sz="1050" dirty="0"/>
           </a:p>
         </p:txBody>
       </p:sp>
@@ -4801,12 +4801,12 @@
         </p:nvSpPr>
         <p:spPr>
           <a:xfrm>
-            <a:off x="3410712" y="2331720"/>
-            <a:ext cx="2697480" cy="3291840"/>
+            <a:off x="2834640" y="2331720"/>
+            <a:ext cx="2212848" cy="3291840"/>
           </a:xfrm>
           <a:prstGeom prst="roundRect">
             <a:avLst>
-              <a:gd name="adj" fmla="val 2712"/>
+              <a:gd name="adj" fmla="val 3306"/>
             </a:avLst>
           </a:prstGeom>
           <a:solidFill>
@@ -4828,8 +4828,8 @@
         </p:nvSpPr>
         <p:spPr>
           <a:xfrm>
-            <a:off x="3593592" y="2560320"/>
-            <a:ext cx="2331720" cy="548640"/>
+            <a:off x="2971800" y="2514600"/>
+            <a:ext cx="1938528" cy="685800"/>
           </a:xfrm>
           <a:prstGeom prst="rect">
             <a:avLst/>
@@ -4845,7 +4845,7 @@
               <a:buNone/>
             </a:pPr>
             <a:r>
-              <a:rPr lang="en-US" sz="1500" b="1" dirty="0">
+              <a:rPr lang="en-US" sz="1300" b="1" dirty="0">
                 <a:solidFill>
                   <a:srgbClr val="E8EDF3"/>
                 </a:solidFill>
@@ -4853,9 +4853,9 @@
                 <a:ea typeface="Calibri" pitchFamily="34" charset="-122"/>
                 <a:cs typeface="Calibri" pitchFamily="34" charset="-120"/>
               </a:rPr>
-              <a:t>bureau</a:t>
-            </a:r>
-            <a:endParaRPr lang="en-US" sz="1500" dirty="0"/>
+              <a:t>bureau + bureau_balance</a:t>
+            </a:r>
+            <a:endParaRPr lang="en-US" sz="1300" dirty="0"/>
           </a:p>
         </p:txBody>
       </p:sp>
@@ -4867,8 +4867,8 @@
         </p:nvSpPr>
         <p:spPr>
           <a:xfrm>
-            <a:off x="3593592" y="3063240"/>
-            <a:ext cx="2331720" cy="365760"/>
+            <a:off x="2971800" y="3154680"/>
+            <a:ext cx="1938528" cy="365760"/>
           </a:xfrm>
           <a:prstGeom prst="rect">
             <a:avLst/>
@@ -4884,7 +4884,7 @@
               <a:buNone/>
             </a:pPr>
             <a:r>
-              <a:rPr lang="en-US" sz="1200" dirty="0">
+              <a:rPr lang="en-US" sz="1050" dirty="0">
                 <a:solidFill>
                   <a:srgbClr val="3FA796"/>
                 </a:solidFill>
@@ -4892,9 +4892,9 @@
                 <a:ea typeface="Consolas" pitchFamily="34" charset="-122"/>
                 <a:cs typeface="Consolas" pitchFamily="34" charset="-120"/>
               </a:rPr>
-              <a:t>1.7M rows</a:t>
-            </a:r>
-            <a:endParaRPr lang="en-US" sz="1200" dirty="0"/>
+              <a:t>1.7M + 27.3M rows</a:t>
+            </a:r>
+            <a:endParaRPr lang="en-US" sz="1050" dirty="0"/>
           </a:p>
         </p:txBody>
       </p:sp>
@@ -4906,8 +4906,8 @@
         </p:nvSpPr>
         <p:spPr>
           <a:xfrm>
-            <a:off x="3593592" y="3520440"/>
-            <a:ext cx="2331720" cy="1920240"/>
+            <a:off x="2971800" y="3566160"/>
+            <a:ext cx="1938528" cy="1920240"/>
           </a:xfrm>
           <a:prstGeom prst="rect">
             <a:avLst/>
@@ -4923,7 +4923,7 @@
               <a:buNone/>
             </a:pPr>
             <a:r>
-              <a:rPr lang="en-US" sz="1150" dirty="0">
+              <a:rPr lang="en-US" sz="1050" dirty="0">
                 <a:solidFill>
                   <a:srgbClr val="8A97AB"/>
                 </a:solidFill>
@@ -4931,9 +4931,9 @@
                 <a:ea typeface="Calibri" pitchFamily="34" charset="-122"/>
                 <a:cs typeface="Calibri" pitchFamily="34" charset="-120"/>
               </a:rPr>
-              <a:t>External credit bureau history — active/overdue loans, debt ratios</a:t>
-            </a:r>
-            <a:endParaRPr lang="en-US" sz="1150" dirty="0"/>
+              <a:t>External credit history &amp; monthly DPD status</a:t>
+            </a:r>
+            <a:endParaRPr lang="en-US" sz="1050" dirty="0"/>
           </a:p>
         </p:txBody>
       </p:sp>
@@ -4945,12 +4945,12 @@
         </p:nvSpPr>
         <p:spPr>
           <a:xfrm>
-            <a:off x="6272784" y="2331720"/>
-            <a:ext cx="2697480" cy="3291840"/>
+            <a:off x="5212080" y="2331720"/>
+            <a:ext cx="2212848" cy="3291840"/>
           </a:xfrm>
           <a:prstGeom prst="roundRect">
             <a:avLst>
-              <a:gd name="adj" fmla="val 2712"/>
+              <a:gd name="adj" fmla="val 3306"/>
             </a:avLst>
           </a:prstGeom>
           <a:solidFill>
@@ -4972,8 +4972,8 @@
         </p:nvSpPr>
         <p:spPr>
           <a:xfrm>
-            <a:off x="6455664" y="2560320"/>
-            <a:ext cx="2331720" cy="548640"/>
+            <a:off x="5349240" y="2514600"/>
+            <a:ext cx="1938528" cy="685800"/>
           </a:xfrm>
           <a:prstGeom prst="rect">
             <a:avLst/>
@@ -4989,7 +4989,7 @@
               <a:buNone/>
             </a:pPr>
             <a:r>
-              <a:rPr lang="en-US" sz="1500" b="1" dirty="0">
+              <a:rPr lang="en-US" sz="1300" b="1" dirty="0">
                 <a:solidFill>
                   <a:srgbClr val="E8EDF3"/>
                 </a:solidFill>
@@ -4999,7 +4999,7 @@
               </a:rPr>
               <a:t>previous_applications</a:t>
             </a:r>
-            <a:endParaRPr lang="en-US" sz="1500" dirty="0"/>
+            <a:endParaRPr lang="en-US" sz="1300" dirty="0"/>
           </a:p>
         </p:txBody>
       </p:sp>
@@ -5011,8 +5011,8 @@
         </p:nvSpPr>
         <p:spPr>
           <a:xfrm>
-            <a:off x="6455664" y="3063240"/>
-            <a:ext cx="2331720" cy="365760"/>
+            <a:off x="5349240" y="3154680"/>
+            <a:ext cx="1938528" cy="365760"/>
           </a:xfrm>
           <a:prstGeom prst="rect">
             <a:avLst/>
@@ -5028,7 +5028,7 @@
               <a:buNone/>
             </a:pPr>
             <a:r>
-              <a:rPr lang="en-US" sz="1200" dirty="0">
+              <a:rPr lang="en-US" sz="1050" dirty="0">
                 <a:solidFill>
                   <a:srgbClr val="3FA796"/>
                 </a:solidFill>
@@ -5038,7 +5038,7 @@
               </a:rPr>
               <a:t>1.7M rows</a:t>
             </a:r>
-            <a:endParaRPr lang="en-US" sz="1200" dirty="0"/>
+            <a:endParaRPr lang="en-US" sz="1050" dirty="0"/>
           </a:p>
         </p:txBody>
       </p:sp>
@@ -5050,8 +5050,8 @@
         </p:nvSpPr>
         <p:spPr>
           <a:xfrm>
-            <a:off x="6455664" y="3520440"/>
-            <a:ext cx="2331720" cy="1920240"/>
+            <a:off x="5349240" y="3566160"/>
+            <a:ext cx="1938528" cy="1920240"/>
           </a:xfrm>
           <a:prstGeom prst="rect">
             <a:avLst/>
@@ -5067,7 +5067,7 @@
               <a:buNone/>
             </a:pPr>
             <a:r>
-              <a:rPr lang="en-US" sz="1150" dirty="0">
+              <a:rPr lang="en-US" sz="1050" dirty="0">
                 <a:solidFill>
                   <a:srgbClr val="8A97AB"/>
                 </a:solidFill>
@@ -5077,7 +5077,7 @@
               </a:rPr>
               <a:t>This applicant's prior loans with the same lender</a:t>
             </a:r>
-            <a:endParaRPr lang="en-US" sz="1150" dirty="0"/>
+            <a:endParaRPr lang="en-US" sz="1050" dirty="0"/>
           </a:p>
         </p:txBody>
       </p:sp>
@@ -5089,12 +5089,12 @@
         </p:nvSpPr>
         <p:spPr>
           <a:xfrm>
-            <a:off x="9134856" y="2331720"/>
-            <a:ext cx="2697480" cy="3291840"/>
+            <a:off x="7589520" y="2331720"/>
+            <a:ext cx="2212848" cy="3291840"/>
           </a:xfrm>
           <a:prstGeom prst="roundRect">
             <a:avLst>
-              <a:gd name="adj" fmla="val 2712"/>
+              <a:gd name="adj" fmla="val 3306"/>
             </a:avLst>
           </a:prstGeom>
           <a:solidFill>
@@ -5116,8 +5116,8 @@
         </p:nvSpPr>
         <p:spPr>
           <a:xfrm>
-            <a:off x="9317736" y="2560320"/>
-            <a:ext cx="2331720" cy="548640"/>
+            <a:off x="7726680" y="2514600"/>
+            <a:ext cx="1938528" cy="685800"/>
           </a:xfrm>
           <a:prstGeom prst="rect">
             <a:avLst/>
@@ -5133,7 +5133,7 @@
               <a:buNone/>
             </a:pPr>
             <a:r>
-              <a:rPr lang="en-US" sz="1500" b="1" dirty="0">
+              <a:rPr lang="en-US" sz="1300" b="1" dirty="0">
                 <a:solidFill>
                   <a:srgbClr val="E8EDF3"/>
                 </a:solidFill>
@@ -5143,7 +5143,7 @@
               </a:rPr>
               <a:t>pos_cash_balance</a:t>
             </a:r>
-            <a:endParaRPr lang="en-US" sz="1500" dirty="0"/>
+            <a:endParaRPr lang="en-US" sz="1300" dirty="0"/>
           </a:p>
         </p:txBody>
       </p:sp>
@@ -5155,8 +5155,8 @@
         </p:nvSpPr>
         <p:spPr>
           <a:xfrm>
-            <a:off x="9317736" y="3063240"/>
-            <a:ext cx="2331720" cy="365760"/>
+            <a:off x="7726680" y="3154680"/>
+            <a:ext cx="1938528" cy="365760"/>
           </a:xfrm>
           <a:prstGeom prst="rect">
             <a:avLst/>
@@ -5172,7 +5172,7 @@
               <a:buNone/>
             </a:pPr>
             <a:r>
-              <a:rPr lang="en-US" sz="1200" dirty="0">
+              <a:rPr lang="en-US" sz="1050" dirty="0">
                 <a:solidFill>
                   <a:srgbClr val="3FA796"/>
                 </a:solidFill>
@@ -5182,7 +5182,7 @@
               </a:rPr>
               <a:t>10M rows</a:t>
             </a:r>
-            <a:endParaRPr lang="en-US" sz="1200" dirty="0"/>
+            <a:endParaRPr lang="en-US" sz="1050" dirty="0"/>
           </a:p>
         </p:txBody>
       </p:sp>
@@ -5194,8 +5194,8 @@
         </p:nvSpPr>
         <p:spPr>
           <a:xfrm>
-            <a:off x="9317736" y="3520440"/>
-            <a:ext cx="2331720" cy="1920240"/>
+            <a:off x="7726680" y="3566160"/>
+            <a:ext cx="1938528" cy="1920240"/>
           </a:xfrm>
           <a:prstGeom prst="rect">
             <a:avLst/>
@@ -5211,7 +5211,7 @@
               <a:buNone/>
             </a:pPr>
             <a:r>
-              <a:rPr lang="en-US" sz="1150" dirty="0">
+              <a:rPr lang="en-US" sz="1050" dirty="0">
                 <a:solidFill>
                   <a:srgbClr val="8A97AB"/>
                 </a:solidFill>
@@ -5219,15 +5219,159 @@
                 <a:ea typeface="Calibri" pitchFamily="34" charset="-122"/>
                 <a:cs typeface="Calibri" pitchFamily="34" charset="-120"/>
               </a:rPr>
-              <a:t>Monthly days-past-due (DPD) — direct repayment behavior signal</a:t>
-            </a:r>
-            <a:endParaRPr lang="en-US" sz="1150" dirty="0"/>
-          </a:p>
-        </p:txBody>
-      </p:sp>
-      <p:sp>
-        <p:nvSpPr>
-          <p:cNvPr id="21" name="Text 19"/>
+              <a:t>Monthly days-past-due (DPD) on cash/POS loans</a:t>
+            </a:r>
+            <a:endParaRPr lang="en-US" sz="1050" dirty="0"/>
+          </a:p>
+        </p:txBody>
+      </p:sp>
+      <p:sp>
+        <p:nvSpPr>
+          <p:cNvPr id="21" name="Shape 19"/>
+          <p:cNvSpPr/>
+          <p:nvPr/>
+        </p:nvSpPr>
+        <p:spPr>
+          <a:xfrm>
+            <a:off x="9966960" y="2331720"/>
+            <a:ext cx="2212848" cy="3291840"/>
+          </a:xfrm>
+          <a:prstGeom prst="roundRect">
+            <a:avLst>
+              <a:gd name="adj" fmla="val 3306"/>
+            </a:avLst>
+          </a:prstGeom>
+          <a:solidFill>
+            <a:srgbClr val="131F30"/>
+          </a:solidFill>
+          <a:ln w="12700">
+            <a:solidFill>
+              <a:srgbClr val="3FA796"/>
+            </a:solidFill>
+            <a:prstDash val="solid"/>
+          </a:ln>
+        </p:spPr>
+      </p:sp>
+      <p:sp>
+        <p:nvSpPr>
+          <p:cNvPr id="22" name="Text 20"/>
+          <p:cNvSpPr txBox="1"/>
+          <p:nvPr/>
+        </p:nvSpPr>
+        <p:spPr>
+          <a:xfrm>
+            <a:off x="10104120" y="2514600"/>
+            <a:ext cx="1938528" cy="685800"/>
+          </a:xfrm>
+          <a:prstGeom prst="rect">
+            <a:avLst/>
+          </a:prstGeom>
+          <a:noFill/>
+          <a:ln/>
+        </p:spPr>
+        <p:txBody>
+          <a:bodyPr wrap="square" rtlCol="0" anchor="ctr"/>
+          <a:lstStyle/>
+          <a:p>
+            <a:pPr indent="0" marL="0">
+              <a:buNone/>
+            </a:pPr>
+            <a:r>
+              <a:rPr lang="en-US" sz="1300" b="1" dirty="0">
+                <a:solidFill>
+                  <a:srgbClr val="E8EDF3"/>
+                </a:solidFill>
+                <a:latin typeface="Calibri" pitchFamily="34" charset="0"/>
+                <a:ea typeface="Calibri" pitchFamily="34" charset="-122"/>
+                <a:cs typeface="Calibri" pitchFamily="34" charset="-120"/>
+              </a:rPr>
+              <a:t>credit_card_balance</a:t>
+            </a:r>
+            <a:endParaRPr lang="en-US" sz="1300" dirty="0"/>
+          </a:p>
+        </p:txBody>
+      </p:sp>
+      <p:sp>
+        <p:nvSpPr>
+          <p:cNvPr id="23" name="Text 21"/>
+          <p:cNvSpPr txBox="1"/>
+          <p:nvPr/>
+        </p:nvSpPr>
+        <p:spPr>
+          <a:xfrm>
+            <a:off x="10104120" y="3154680"/>
+            <a:ext cx="1938528" cy="365760"/>
+          </a:xfrm>
+          <a:prstGeom prst="rect">
+            <a:avLst/>
+          </a:prstGeom>
+          <a:noFill/>
+          <a:ln/>
+        </p:spPr>
+        <p:txBody>
+          <a:bodyPr wrap="square" rtlCol="0" anchor="ctr"/>
+          <a:lstStyle/>
+          <a:p>
+            <a:pPr indent="0" marL="0">
+              <a:buNone/>
+            </a:pPr>
+            <a:r>
+              <a:rPr lang="en-US" sz="1050" dirty="0">
+                <a:solidFill>
+                  <a:srgbClr val="3FA796"/>
+                </a:solidFill>
+                <a:latin typeface="Consolas" pitchFamily="34" charset="0"/>
+                <a:ea typeface="Consolas" pitchFamily="34" charset="-122"/>
+                <a:cs typeface="Consolas" pitchFamily="34" charset="-120"/>
+              </a:rPr>
+              <a:t>3.8M rows</a:t>
+            </a:r>
+            <a:endParaRPr lang="en-US" sz="1050" dirty="0"/>
+          </a:p>
+        </p:txBody>
+      </p:sp>
+      <p:sp>
+        <p:nvSpPr>
+          <p:cNvPr id="24" name="Text 22"/>
+          <p:cNvSpPr txBox="1"/>
+          <p:nvPr/>
+        </p:nvSpPr>
+        <p:spPr>
+          <a:xfrm>
+            <a:off x="10104120" y="3566160"/>
+            <a:ext cx="1938528" cy="1920240"/>
+          </a:xfrm>
+          <a:prstGeom prst="rect">
+            <a:avLst/>
+          </a:prstGeom>
+          <a:noFill/>
+          <a:ln/>
+        </p:spPr>
+        <p:txBody>
+          <a:bodyPr wrap="square" rtlCol="0" anchor="ctr"/>
+          <a:lstStyle/>
+          <a:p>
+            <a:pPr indent="0" marL="0">
+              <a:buNone/>
+            </a:pPr>
+            <a:r>
+              <a:rPr lang="en-US" sz="1050" dirty="0">
+                <a:solidFill>
+                  <a:srgbClr val="8A97AB"/>
+                </a:solidFill>
+                <a:latin typeface="Calibri" pitchFamily="34" charset="0"/>
+                <a:ea typeface="Calibri" pitchFamily="34" charset="-122"/>
+                <a:cs typeface="Calibri" pitchFamily="34" charset="-120"/>
+              </a:rPr>
+              <a:t>Monthly card balance &amp; utilization — new default-risk signal</a:t>
+            </a:r>
+            <a:endParaRPr lang="en-US" sz="1050" dirty="0"/>
+          </a:p>
+        </p:txBody>
+      </p:sp>
+      <p:sp>
+        <p:nvSpPr>
+          <p:cNvPr id="25" name="Text 23"/>
           <p:cNvSpPr txBox="1"/>
           <p:nvPr/>
         </p:nvSpPr>
@@ -5258,7 +5402,7 @@
                 <a:ea typeface="Calibri" pitchFamily="34" charset="-122"/>
                 <a:cs typeface="Calibri" pitchFamily="34" charset="-120"/>
               </a:rPr>
-              <a:t>Result: 152 features across 4 tables, feeding a single unified model.</a:t>
+              <a:t>Result: 165 features across 6 tables, feeding a single unified model.</a:t>
             </a:r>
             <a:endParaRPr lang="en-US" sz="1300" dirty="0"/>
           </a:p>
@@ -5266,7 +5410,7 @@
       </p:sp>
       <p:sp>
         <p:nvSpPr>
-          <p:cNvPr id="22" name="Text 20"/>
+          <p:cNvPr id="26" name="Text 24"/>
           <p:cNvSpPr txBox="1"/>
           <p:nvPr/>
         </p:nvSpPr>
@@ -5767,7 +5911,7 @@
                 <a:ea typeface="Consolas" pitchFamily="34" charset="-122"/>
                 <a:cs typeface="Consolas" pitchFamily="34" charset="-120"/>
               </a:rPr>
-              <a:t>0.778</a:t>
+              <a:t>0.780</a:t>
             </a:r>
             <a:endParaRPr lang="en-US" sz="2600" dirty="0"/>
           </a:p>
@@ -5872,7 +6016,7 @@
                 <a:ea typeface="Consolas" pitchFamily="34" charset="-122"/>
                 <a:cs typeface="Consolas" pitchFamily="34" charset="-120"/>
               </a:rPr>
-              <a:t>0.273</a:t>
+              <a:t>0.277</a:t>
             </a:r>
             <a:endParaRPr lang="en-US" sz="2600" dirty="0"/>
           </a:p>
@@ -5977,7 +6121,7 @@
                 <a:ea typeface="Consolas" pitchFamily="34" charset="-122"/>
                 <a:cs typeface="Consolas" pitchFamily="34" charset="-120"/>
               </a:rPr>
-              <a:t>66.2%</a:t>
+              <a:t>66.7%</a:t>
             </a:r>
             <a:endParaRPr lang="en-US" sz="2600" dirty="0"/>
           </a:p>
@@ -6082,7 +6226,7 @@
                 <a:ea typeface="Consolas" pitchFamily="34" charset="-122"/>
                 <a:cs typeface="Consolas" pitchFamily="34" charset="-120"/>
               </a:rPr>
-              <a:t>152</a:t>
+              <a:t>165</a:t>
             </a:r>
             <a:endParaRPr lang="en-US" sz="2600" dirty="0"/>
           </a:p>
@@ -6446,7 +6590,7 @@
                           <a:ea typeface="Calibri" pitchFamily="34" charset="-122"/>
                           <a:cs typeface="Calibri" pitchFamily="34" charset="-120"/>
                         </a:rPr>
-                        <a:t>0.7782</a:t>
+                        <a:t>0.7804</a:t>
                       </a:r>
                       <a:endParaRPr lang="en-US" sz="1250" dirty="0">
                         <a:latin typeface="Calibri" charset="0"/>
@@ -6652,7 +6796,7 @@
                           <a:ea typeface="Calibri" pitchFamily="34" charset="-122"/>
                           <a:cs typeface="Calibri" pitchFamily="34" charset="-120"/>
                         </a:rPr>
-                        <a:t>0.7793</a:t>
+                        <a:t>0.7792</a:t>
                       </a:r>
                       <a:endParaRPr lang="en-US" sz="1250" dirty="0">
                         <a:latin typeface="Calibri" charset="0"/>
@@ -7691,7 +7835,7 @@
                 <a:ea typeface="Calibri" pitchFamily="34" charset="-122"/>
                 <a:cs typeface="Calibri" pitchFamily="34" charset="-120"/>
               </a:rPr>
-              <a:t>6 verified working query patterns (exceeds the required 5)</a:t>
+              <a:t>7 verified working query patterns (exceeds the required 5)</a:t>
             </a:r>
             <a:endParaRPr lang="en-US" sz="1180" dirty="0"/>
           </a:p>

</xml_diff>

<commit_message>
Humanize the presentation: personal voice at the narrative beats
- Title slide: added a byline and a note that every number is from a real run
- Objective slide: reframed as 'how I thought about this problem' with a
  first-person intro sentence
- Limitations slide: reframed as an honest, reflective 'what I'd do next'
  rather than a dry bullet list
- Closing slide: replaced generic 'Thank you' with a genuine personal note
  inviting discussion, signed with name
- Kept the technical middle slides (architecture, ML, SHAP, rules, chatbot,
  deployment) precise and professional — personality lives at the emotional
  beats, not throughout, so it reads as genuine rather than performative
</commit_message>
<xml_diff>
--- a/documents/Credit_Risk_Platform_Presentation.pptx
+++ b/documents/Credit_Risk_Platform_Presentation.pptx
@@ -2049,8 +2049,8 @@
         </p:nvSpPr>
         <p:spPr>
           <a:xfrm>
-            <a:off x="822960" y="6126480"/>
-            <a:ext cx="7315200" cy="365760"/>
+            <a:off x="822960" y="5989320"/>
+            <a:ext cx="8229600" cy="365760"/>
           </a:xfrm>
           <a:prstGeom prst="rect">
             <a:avLst/>
@@ -2066,7 +2066,46 @@
               <a:buNone/>
             </a:pPr>
             <a:r>
-              <a:rPr lang="en-US" sz="1200" dirty="0">
+              <a:rPr lang="en-US" sz="1250" b="1" dirty="0">
+                <a:solidFill>
+                  <a:srgbClr val="E8EDF3"/>
+                </a:solidFill>
+                <a:latin typeface="Calibri" pitchFamily="34" charset="0"/>
+                <a:ea typeface="Calibri" pitchFamily="34" charset="-122"/>
+                <a:cs typeface="Calibri" pitchFamily="34" charset="-120"/>
+              </a:rPr>
+              <a:t>Built by Malavika Krishna, for the NeoStats AI Engineer Internship</a:t>
+            </a:r>
+            <a:endParaRPr lang="en-US" sz="1250" dirty="0"/>
+          </a:p>
+        </p:txBody>
+      </p:sp>
+      <p:sp>
+        <p:nvSpPr>
+          <p:cNvPr id="6" name="Text 4"/>
+          <p:cNvSpPr txBox="1"/>
+          <p:nvPr/>
+        </p:nvSpPr>
+        <p:spPr>
+          <a:xfrm>
+            <a:off x="822960" y="6309360"/>
+            <a:ext cx="9601200" cy="365760"/>
+          </a:xfrm>
+          <a:prstGeom prst="rect">
+            <a:avLst/>
+          </a:prstGeom>
+          <a:noFill/>
+          <a:ln/>
+        </p:spPr>
+        <p:txBody>
+          <a:bodyPr wrap="square" rtlCol="0" anchor="ctr"/>
+          <a:lstStyle/>
+          <a:p>
+            <a:pPr indent="0" marL="0">
+              <a:buNone/>
+            </a:pPr>
+            <a:r>
+              <a:rPr lang="en-US" sz="1100" i="1" dirty="0">
                 <a:solidFill>
                   <a:srgbClr val="8A97AB"/>
                 </a:solidFill>
@@ -2074,9 +2113,9 @@
                 <a:ea typeface="Calibri" pitchFamily="34" charset="-122"/>
                 <a:cs typeface="Calibri" pitchFamily="34" charset="-120"/>
               </a:rPr>
-              <a:t>NeoStats AI Engineer Internship — Candidate Assignment</a:t>
-            </a:r>
-            <a:endParaRPr lang="en-US" sz="1200" dirty="0"/>
+              <a:t>Candidate Assignment — every number in this deck comes from a real run against the actual dataset, not a mockup</a:t>
+            </a:r>
+            <a:endParaRPr lang="en-US" sz="1100" dirty="0"/>
           </a:p>
         </p:txBody>
       </p:sp>
@@ -3085,7 +3124,7 @@
                 <a:ea typeface="Calibri" pitchFamily="34" charset="-122"/>
                 <a:cs typeface="Calibri" pitchFamily="34" charset="-120"/>
               </a:rPr>
-              <a:t>HONEST SCOPE</a:t>
+              <a:t>BEING HONEST WITH YOU</a:t>
             </a:r>
             <a:endParaRPr lang="en-US" sz="1200" dirty="0"/>
           </a:p>
@@ -3124,7 +3163,7 @@
                 <a:ea typeface="Calibri" pitchFamily="34" charset="-122"/>
                 <a:cs typeface="Calibri" pitchFamily="34" charset="-120"/>
               </a:rPr>
-              <a:t>Known limitations &amp; what's next</a:t>
+              <a:t>What I'd do next, if I kept going</a:t>
             </a:r>
             <a:endParaRPr lang="en-US" sz="3000" dirty="0"/>
           </a:p>
@@ -3132,18 +3171,57 @@
       </p:sp>
       <p:sp>
         <p:nvSpPr>
-          <p:cNvPr id="4" name="Shape 2"/>
+          <p:cNvPr id="4" name="Text 2"/>
+          <p:cNvSpPr txBox="1"/>
+          <p:nvPr/>
+        </p:nvSpPr>
+        <p:spPr>
+          <a:xfrm>
+            <a:off x="548640" y="1371600"/>
+            <a:ext cx="11064240" cy="411480"/>
+          </a:xfrm>
+          <a:prstGeom prst="rect">
+            <a:avLst/>
+          </a:prstGeom>
+          <a:noFill/>
+          <a:ln/>
+        </p:spPr>
+        <p:txBody>
+          <a:bodyPr wrap="square" rtlCol="0" anchor="ctr"/>
+          <a:lstStyle/>
+          <a:p>
+            <a:pPr indent="0" marL="0">
+              <a:buNone/>
+            </a:pPr>
+            <a:r>
+              <a:rPr lang="en-US" sz="1250" i="1" dirty="0">
+                <a:solidFill>
+                  <a:srgbClr val="8A97AB"/>
+                </a:solidFill>
+                <a:latin typeface="Calibri" pitchFamily="34" charset="0"/>
+                <a:ea typeface="Calibri" pitchFamily="34" charset="-122"/>
+                <a:cs typeface="Calibri" pitchFamily="34" charset="-120"/>
+              </a:rPr>
+              <a:t>I'd rather show you exactly where the edges are than pretend this is finished. Here's what I'd tackle first with more time:</a:t>
+            </a:r>
+            <a:endParaRPr lang="en-US" sz="1250" dirty="0"/>
+          </a:p>
+        </p:txBody>
+      </p:sp>
+      <p:sp>
+        <p:nvSpPr>
+          <p:cNvPr id="5" name="Shape 3"/>
           <p:cNvSpPr/>
           <p:nvPr/>
         </p:nvSpPr>
         <p:spPr>
           <a:xfrm>
-            <a:off x="548640" y="1554480"/>
-            <a:ext cx="11064240" cy="1051560"/>
+            <a:off x="548640" y="1965960"/>
+            <a:ext cx="11064240" cy="987552"/>
           </a:xfrm>
           <a:prstGeom prst="roundRect">
             <a:avLst>
-              <a:gd name="adj" fmla="val 6957"/>
+              <a:gd name="adj" fmla="val 7407"/>
             </a:avLst>
           </a:prstGeom>
           <a:solidFill>
@@ -3159,13 +3237,13 @@
       </p:sp>
       <p:sp>
         <p:nvSpPr>
-          <p:cNvPr id="5" name="Text 3"/>
-          <p:cNvSpPr txBox="1"/>
-          <p:nvPr/>
-        </p:nvSpPr>
-        <p:spPr>
-          <a:xfrm>
-            <a:off x="868680" y="1664208"/>
+          <p:cNvPr id="6" name="Text 4"/>
+          <p:cNvSpPr txBox="1"/>
+          <p:nvPr/>
+        </p:nvSpPr>
+        <p:spPr>
+          <a:xfrm>
+            <a:off x="868680" y="2057400"/>
             <a:ext cx="10424160" cy="365760"/>
           </a:xfrm>
           <a:prstGeom prst="rect">
@@ -3198,14 +3276,14 @@
       </p:sp>
       <p:sp>
         <p:nvSpPr>
-          <p:cNvPr id="6" name="Text 4"/>
-          <p:cNvSpPr txBox="1"/>
-          <p:nvPr/>
-        </p:nvSpPr>
-        <p:spPr>
-          <a:xfrm>
-            <a:off x="868680" y="2039112"/>
-            <a:ext cx="10424160" cy="502920"/>
+          <p:cNvPr id="7" name="Text 5"/>
+          <p:cNvSpPr txBox="1"/>
+          <p:nvPr/>
+        </p:nvSpPr>
+        <p:spPr>
+          <a:xfrm>
+            <a:off x="868680" y="2404872"/>
+            <a:ext cx="10424160" cy="457200"/>
           </a:xfrm>
           <a:prstGeom prst="rect">
             <a:avLst/>
@@ -3237,18 +3315,18 @@
       </p:sp>
       <p:sp>
         <p:nvSpPr>
-          <p:cNvPr id="7" name="Shape 5"/>
+          <p:cNvPr id="8" name="Shape 6"/>
           <p:cNvSpPr/>
           <p:nvPr/>
         </p:nvSpPr>
         <p:spPr>
           <a:xfrm>
-            <a:off x="548640" y="2761488"/>
-            <a:ext cx="11064240" cy="1051560"/>
+            <a:off x="548640" y="3081528"/>
+            <a:ext cx="11064240" cy="987552"/>
           </a:xfrm>
           <a:prstGeom prst="roundRect">
             <a:avLst>
-              <a:gd name="adj" fmla="val 6957"/>
+              <a:gd name="adj" fmla="val 7407"/>
             </a:avLst>
           </a:prstGeom>
           <a:solidFill>
@@ -3264,13 +3342,13 @@
       </p:sp>
       <p:sp>
         <p:nvSpPr>
-          <p:cNvPr id="8" name="Text 6"/>
-          <p:cNvSpPr txBox="1"/>
-          <p:nvPr/>
-        </p:nvSpPr>
-        <p:spPr>
-          <a:xfrm>
-            <a:off x="868680" y="2871216"/>
+          <p:cNvPr id="9" name="Text 7"/>
+          <p:cNvSpPr txBox="1"/>
+          <p:nvPr/>
+        </p:nvSpPr>
+        <p:spPr>
+          <a:xfrm>
+            <a:off x="868680" y="3172968"/>
             <a:ext cx="10424160" cy="365760"/>
           </a:xfrm>
           <a:prstGeom prst="rect">
@@ -3303,14 +3381,14 @@
       </p:sp>
       <p:sp>
         <p:nvSpPr>
-          <p:cNvPr id="9" name="Text 7"/>
-          <p:cNvSpPr txBox="1"/>
-          <p:nvPr/>
-        </p:nvSpPr>
-        <p:spPr>
-          <a:xfrm>
-            <a:off x="868680" y="3246120"/>
-            <a:ext cx="10424160" cy="502920"/>
+          <p:cNvPr id="10" name="Text 8"/>
+          <p:cNvSpPr txBox="1"/>
+          <p:nvPr/>
+        </p:nvSpPr>
+        <p:spPr>
+          <a:xfrm>
+            <a:off x="868680" y="3520440"/>
+            <a:ext cx="10424160" cy="457200"/>
           </a:xfrm>
           <a:prstGeom prst="rect">
             <a:avLst/>
@@ -3342,18 +3420,18 @@
       </p:sp>
       <p:sp>
         <p:nvSpPr>
-          <p:cNvPr id="10" name="Shape 8"/>
+          <p:cNvPr id="11" name="Shape 9"/>
           <p:cNvSpPr/>
           <p:nvPr/>
         </p:nvSpPr>
         <p:spPr>
           <a:xfrm>
-            <a:off x="548640" y="3968496"/>
-            <a:ext cx="11064240" cy="1051560"/>
+            <a:off x="548640" y="4197096"/>
+            <a:ext cx="11064240" cy="987552"/>
           </a:xfrm>
           <a:prstGeom prst="roundRect">
             <a:avLst>
-              <a:gd name="adj" fmla="val 6957"/>
+              <a:gd name="adj" fmla="val 7407"/>
             </a:avLst>
           </a:prstGeom>
           <a:solidFill>
@@ -3369,13 +3447,13 @@
       </p:sp>
       <p:sp>
         <p:nvSpPr>
-          <p:cNvPr id="11" name="Text 9"/>
-          <p:cNvSpPr txBox="1"/>
-          <p:nvPr/>
-        </p:nvSpPr>
-        <p:spPr>
-          <a:xfrm>
-            <a:off x="868680" y="4078224"/>
+          <p:cNvPr id="12" name="Text 10"/>
+          <p:cNvSpPr txBox="1"/>
+          <p:nvPr/>
+        </p:nvSpPr>
+        <p:spPr>
+          <a:xfrm>
+            <a:off x="868680" y="4288536"/>
             <a:ext cx="10424160" cy="365760"/>
           </a:xfrm>
           <a:prstGeom prst="rect">
@@ -3408,14 +3486,14 @@
       </p:sp>
       <p:sp>
         <p:nvSpPr>
-          <p:cNvPr id="12" name="Text 10"/>
-          <p:cNvSpPr txBox="1"/>
-          <p:nvPr/>
-        </p:nvSpPr>
-        <p:spPr>
-          <a:xfrm>
-            <a:off x="868680" y="4453128"/>
-            <a:ext cx="10424160" cy="502920"/>
+          <p:cNvPr id="13" name="Text 11"/>
+          <p:cNvSpPr txBox="1"/>
+          <p:nvPr/>
+        </p:nvSpPr>
+        <p:spPr>
+          <a:xfrm>
+            <a:off x="868680" y="4636008"/>
+            <a:ext cx="10424160" cy="457200"/>
           </a:xfrm>
           <a:prstGeom prst="rect">
             <a:avLst/>
@@ -3447,18 +3525,18 @@
       </p:sp>
       <p:sp>
         <p:nvSpPr>
-          <p:cNvPr id="13" name="Shape 11"/>
+          <p:cNvPr id="14" name="Shape 12"/>
           <p:cNvSpPr/>
           <p:nvPr/>
         </p:nvSpPr>
         <p:spPr>
           <a:xfrm>
-            <a:off x="548640" y="5175504"/>
-            <a:ext cx="11064240" cy="1051560"/>
+            <a:off x="548640" y="5312664"/>
+            <a:ext cx="11064240" cy="987552"/>
           </a:xfrm>
           <a:prstGeom prst="roundRect">
             <a:avLst>
-              <a:gd name="adj" fmla="val 6957"/>
+              <a:gd name="adj" fmla="val 7407"/>
             </a:avLst>
           </a:prstGeom>
           <a:solidFill>
@@ -3474,13 +3552,13 @@
       </p:sp>
       <p:sp>
         <p:nvSpPr>
-          <p:cNvPr id="14" name="Text 12"/>
-          <p:cNvSpPr txBox="1"/>
-          <p:nvPr/>
-        </p:nvSpPr>
-        <p:spPr>
-          <a:xfrm>
-            <a:off x="868680" y="5285232"/>
+          <p:cNvPr id="15" name="Text 13"/>
+          <p:cNvSpPr txBox="1"/>
+          <p:nvPr/>
+        </p:nvSpPr>
+        <p:spPr>
+          <a:xfrm>
+            <a:off x="868680" y="5404104"/>
             <a:ext cx="10424160" cy="365760"/>
           </a:xfrm>
           <a:prstGeom prst="rect">
@@ -3513,14 +3591,14 @@
       </p:sp>
       <p:sp>
         <p:nvSpPr>
-          <p:cNvPr id="15" name="Text 13"/>
-          <p:cNvSpPr txBox="1"/>
-          <p:nvPr/>
-        </p:nvSpPr>
-        <p:spPr>
-          <a:xfrm>
-            <a:off x="868680" y="5660136"/>
-            <a:ext cx="10424160" cy="502920"/>
+          <p:cNvPr id="16" name="Text 14"/>
+          <p:cNvSpPr txBox="1"/>
+          <p:nvPr/>
+        </p:nvSpPr>
+        <p:spPr>
+          <a:xfrm>
+            <a:off x="868680" y="5751576"/>
+            <a:ext cx="10424160" cy="457200"/>
           </a:xfrm>
           <a:prstGeom prst="rect">
             <a:avLst/>
@@ -3552,7 +3630,7 @@
       </p:sp>
       <p:sp>
         <p:nvSpPr>
-          <p:cNvPr id="16" name="Text 14"/>
+          <p:cNvPr id="17" name="Text 15"/>
           <p:cNvSpPr txBox="1"/>
           <p:nvPr/>
         </p:nvSpPr>
@@ -3629,8 +3707,8 @@
         </p:nvSpPr>
         <p:spPr>
           <a:xfrm>
-            <a:off x="822960" y="2651760"/>
-            <a:ext cx="9144000" cy="914400"/>
+            <a:off x="822960" y="2103120"/>
+            <a:ext cx="10058400" cy="914400"/>
           </a:xfrm>
           <a:prstGeom prst="rect">
             <a:avLst/>
@@ -3646,7 +3724,7 @@
               <a:buNone/>
             </a:pPr>
             <a:r>
-              <a:rPr lang="en-US" sz="4000" b="1" dirty="0">
+              <a:rPr lang="en-US" sz="3600" b="1" dirty="0">
                 <a:solidFill>
                   <a:srgbClr val="E8EDF3"/>
                 </a:solidFill>
@@ -3654,9 +3732,9 @@
                 <a:ea typeface="Calibri" pitchFamily="34" charset="-122"/>
                 <a:cs typeface="Calibri" pitchFamily="34" charset="-120"/>
               </a:rPr>
-              <a:t>Thank you</a:t>
-            </a:r>
-            <a:endParaRPr lang="en-US" sz="4000" dirty="0"/>
+              <a:t>Thank you for reading this far</a:t>
+            </a:r>
+            <a:endParaRPr lang="en-US" sz="3600" dirty="0"/>
           </a:p>
         </p:txBody>
       </p:sp>
@@ -3668,8 +3746,8 @@
         </p:nvSpPr>
         <p:spPr>
           <a:xfrm>
-            <a:off x="822960" y="3474720"/>
-            <a:ext cx="9144000" cy="457200"/>
+            <a:off x="822960" y="3063240"/>
+            <a:ext cx="9875520" cy="1005840"/>
           </a:xfrm>
           <a:prstGeom prst="rect">
             <a:avLst/>
@@ -3682,10 +3760,13 @@
           <a:lstStyle/>
           <a:p>
             <a:pPr indent="0" marL="0">
-              <a:buNone/>
-            </a:pPr>
-            <a:r>
-              <a:rPr lang="en-US" sz="1500" dirty="0">
+              <a:lnSpc>
+                <a:spcPct val="130000"/>
+              </a:lnSpc>
+              <a:buNone/>
+            </a:pPr>
+            <a:r>
+              <a:rPr lang="en-US" sz="1450" dirty="0">
                 <a:solidFill>
                   <a:srgbClr val="8A97AB"/>
                 </a:solidFill>
@@ -3693,9 +3774,9 @@
                 <a:ea typeface="Calibri" pitchFamily="34" charset="-122"/>
                 <a:cs typeface="Calibri" pitchFamily="34" charset="-120"/>
               </a:rPr>
-              <a:t>Credit Risk Intelligence Platform — built end-to-end with real data, tested at every stage</a:t>
-            </a:r>
-            <a:endParaRPr lang="en-US" sz="1500" dirty="0"/>
+              <a:t>I genuinely enjoyed building this — the multi-table joins, the SQL guardrails, the SHAP explanations that turned out to match intuition. If you dig into the repo and something looks off or you'd want it done differently, I'd love to talk through the reasoning.</a:t>
+            </a:r>
+            <a:endParaRPr lang="en-US" sz="1450" dirty="0"/>
           </a:p>
         </p:txBody>
       </p:sp>
@@ -3707,7 +3788,7 @@
         </p:nvSpPr>
         <p:spPr>
           <a:xfrm>
-            <a:off x="822960" y="4023360"/>
+            <a:off x="822960" y="4297680"/>
             <a:ext cx="502920" cy="54864"/>
           </a:xfrm>
           <a:prstGeom prst="rect">
@@ -3722,6 +3803,45 @@
       <p:sp>
         <p:nvSpPr>
           <p:cNvPr id="5" name="Text 3"/>
+          <p:cNvSpPr txBox="1"/>
+          <p:nvPr/>
+        </p:nvSpPr>
+        <p:spPr>
+          <a:xfrm>
+            <a:off x="822960" y="5806440"/>
+            <a:ext cx="7315200" cy="365760"/>
+          </a:xfrm>
+          <a:prstGeom prst="rect">
+            <a:avLst/>
+          </a:prstGeom>
+          <a:noFill/>
+          <a:ln/>
+        </p:spPr>
+        <p:txBody>
+          <a:bodyPr wrap="square" rtlCol="0" anchor="ctr"/>
+          <a:lstStyle/>
+          <a:p>
+            <a:pPr indent="0" marL="0">
+              <a:buNone/>
+            </a:pPr>
+            <a:r>
+              <a:rPr lang="en-US" sz="1300" b="1" dirty="0">
+                <a:solidFill>
+                  <a:srgbClr val="E8EDF3"/>
+                </a:solidFill>
+                <a:latin typeface="Calibri" pitchFamily="34" charset="0"/>
+                <a:ea typeface="Calibri" pitchFamily="34" charset="-122"/>
+                <a:cs typeface="Calibri" pitchFamily="34" charset="-120"/>
+              </a:rPr>
+              <a:t>Malavika Krishna</a:t>
+            </a:r>
+            <a:endParaRPr lang="en-US" sz="1300" dirty="0"/>
+          </a:p>
+        </p:txBody>
+      </p:sp>
+      <p:sp>
+        <p:nvSpPr>
+          <p:cNvPr id="6" name="Text 4"/>
           <p:cNvSpPr txBox="1"/>
           <p:nvPr/>
         </p:nvSpPr>
@@ -3823,7 +3943,7 @@
                 <a:ea typeface="Calibri" pitchFamily="34" charset="-122"/>
                 <a:cs typeface="Calibri" pitchFamily="34" charset="-120"/>
               </a:rPr>
-              <a:t>OBJECTIVE</a:t>
+              <a:t>MY APPROACH</a:t>
             </a:r>
             <a:endParaRPr lang="en-US" sz="1200" dirty="0"/>
           </a:p>
@@ -3862,7 +3982,7 @@
                 <a:ea typeface="Calibri" pitchFamily="34" charset="-122"/>
                 <a:cs typeface="Calibri" pitchFamily="34" charset="-120"/>
               </a:rPr>
-              <a:t>Building a bank-ready credit risk platform</a:t>
+              <a:t>How I thought about this problem</a:t>
             </a:r>
             <a:endParaRPr lang="en-US" sz="3000" dirty="0"/>
           </a:p>
@@ -3870,18 +3990,57 @@
       </p:sp>
       <p:sp>
         <p:nvSpPr>
-          <p:cNvPr id="4" name="Shape 2"/>
+          <p:cNvPr id="4" name="Text 2"/>
+          <p:cNvSpPr txBox="1"/>
+          <p:nvPr/>
+        </p:nvSpPr>
+        <p:spPr>
+          <a:xfrm>
+            <a:off x="548640" y="1417320"/>
+            <a:ext cx="11064240" cy="457200"/>
+          </a:xfrm>
+          <a:prstGeom prst="rect">
+            <a:avLst/>
+          </a:prstGeom>
+          <a:noFill/>
+          <a:ln/>
+        </p:spPr>
+        <p:txBody>
+          <a:bodyPr wrap="square" rtlCol="0" anchor="ctr"/>
+          <a:lstStyle/>
+          <a:p>
+            <a:pPr indent="0" marL="0">
+              <a:buNone/>
+            </a:pPr>
+            <a:r>
+              <a:rPr lang="en-US" sz="1300" i="1" dirty="0">
+                <a:solidFill>
+                  <a:srgbClr val="8A97AB"/>
+                </a:solidFill>
+                <a:latin typeface="Calibri" pitchFamily="34" charset="0"/>
+                <a:ea typeface="Calibri" pitchFamily="34" charset="-122"/>
+                <a:cs typeface="Calibri" pitchFamily="34" charset="-120"/>
+              </a:rPr>
+              <a:t>Most take-home submissions on this dataset stop at a single CSV and a model score. I wanted to build something a real credit team could actually use — so I optimized for four things:</a:t>
+            </a:r>
+            <a:endParaRPr lang="en-US" sz="1300" dirty="0"/>
+          </a:p>
+        </p:txBody>
+      </p:sp>
+      <p:sp>
+        <p:nvSpPr>
+          <p:cNvPr id="5" name="Shape 3"/>
           <p:cNvSpPr/>
           <p:nvPr/>
         </p:nvSpPr>
         <p:spPr>
           <a:xfrm>
-            <a:off x="548640" y="1600200"/>
-            <a:ext cx="11064240" cy="960120"/>
+            <a:off x="548640" y="2057400"/>
+            <a:ext cx="11064240" cy="868680"/>
           </a:xfrm>
           <a:prstGeom prst="roundRect">
             <a:avLst>
-              <a:gd name="adj" fmla="val 7619"/>
+              <a:gd name="adj" fmla="val 8421"/>
             </a:avLst>
           </a:prstGeom>
           <a:solidFill>
@@ -3897,13 +4056,13 @@
       </p:sp>
       <p:sp>
         <p:nvSpPr>
-          <p:cNvPr id="5" name="Text 3"/>
-          <p:cNvSpPr txBox="1"/>
-          <p:nvPr/>
-        </p:nvSpPr>
-        <p:spPr>
-          <a:xfrm>
-            <a:off x="868680" y="1709928"/>
+          <p:cNvPr id="6" name="Text 4"/>
+          <p:cNvSpPr txBox="1"/>
+          <p:nvPr/>
+        </p:nvSpPr>
+        <p:spPr>
+          <a:xfrm>
+            <a:off x="868680" y="2148840"/>
             <a:ext cx="3657600" cy="365760"/>
           </a:xfrm>
           <a:prstGeom prst="rect">
@@ -3936,14 +4095,14 @@
       </p:sp>
       <p:sp>
         <p:nvSpPr>
-          <p:cNvPr id="6" name="Text 4"/>
-          <p:cNvSpPr txBox="1"/>
-          <p:nvPr/>
-        </p:nvSpPr>
-        <p:spPr>
-          <a:xfrm>
-            <a:off x="868680" y="2057400"/>
-            <a:ext cx="10424160" cy="411480"/>
+          <p:cNvPr id="7" name="Text 5"/>
+          <p:cNvSpPr txBox="1"/>
+          <p:nvPr/>
+        </p:nvSpPr>
+        <p:spPr>
+          <a:xfrm>
+            <a:off x="868680" y="2478024"/>
+            <a:ext cx="10424160" cy="384048"/>
           </a:xfrm>
           <a:prstGeom prst="rect">
             <a:avLst/>
@@ -3975,18 +4134,18 @@
       </p:sp>
       <p:sp>
         <p:nvSpPr>
-          <p:cNvPr id="7" name="Shape 5"/>
+          <p:cNvPr id="8" name="Shape 6"/>
           <p:cNvSpPr/>
           <p:nvPr/>
         </p:nvSpPr>
         <p:spPr>
           <a:xfrm>
-            <a:off x="548640" y="2715768"/>
-            <a:ext cx="11064240" cy="960120"/>
+            <a:off x="548640" y="3063240"/>
+            <a:ext cx="11064240" cy="868680"/>
           </a:xfrm>
           <a:prstGeom prst="roundRect">
             <a:avLst>
-              <a:gd name="adj" fmla="val 7619"/>
+              <a:gd name="adj" fmla="val 8421"/>
             </a:avLst>
           </a:prstGeom>
           <a:solidFill>
@@ -4002,13 +4161,13 @@
       </p:sp>
       <p:sp>
         <p:nvSpPr>
-          <p:cNvPr id="8" name="Text 6"/>
-          <p:cNvSpPr txBox="1"/>
-          <p:nvPr/>
-        </p:nvSpPr>
-        <p:spPr>
-          <a:xfrm>
-            <a:off x="868680" y="2825496"/>
+          <p:cNvPr id="9" name="Text 7"/>
+          <p:cNvSpPr txBox="1"/>
+          <p:nvPr/>
+        </p:nvSpPr>
+        <p:spPr>
+          <a:xfrm>
+            <a:off x="868680" y="3154680"/>
             <a:ext cx="3657600" cy="365760"/>
           </a:xfrm>
           <a:prstGeom prst="rect">
@@ -4041,14 +4200,14 @@
       </p:sp>
       <p:sp>
         <p:nvSpPr>
-          <p:cNvPr id="9" name="Text 7"/>
-          <p:cNvSpPr txBox="1"/>
-          <p:nvPr/>
-        </p:nvSpPr>
-        <p:spPr>
-          <a:xfrm>
-            <a:off x="868680" y="3172968"/>
-            <a:ext cx="10424160" cy="411480"/>
+          <p:cNvPr id="10" name="Text 8"/>
+          <p:cNvSpPr txBox="1"/>
+          <p:nvPr/>
+        </p:nvSpPr>
+        <p:spPr>
+          <a:xfrm>
+            <a:off x="868680" y="3483864"/>
+            <a:ext cx="10424160" cy="384048"/>
           </a:xfrm>
           <a:prstGeom prst="rect">
             <a:avLst/>
@@ -4080,18 +4239,18 @@
       </p:sp>
       <p:sp>
         <p:nvSpPr>
-          <p:cNvPr id="10" name="Shape 8"/>
+          <p:cNvPr id="11" name="Shape 9"/>
           <p:cNvSpPr/>
           <p:nvPr/>
         </p:nvSpPr>
         <p:spPr>
           <a:xfrm>
-            <a:off x="548640" y="3831336"/>
-            <a:ext cx="11064240" cy="960120"/>
+            <a:off x="548640" y="4069080"/>
+            <a:ext cx="11064240" cy="868680"/>
           </a:xfrm>
           <a:prstGeom prst="roundRect">
             <a:avLst>
-              <a:gd name="adj" fmla="val 7619"/>
+              <a:gd name="adj" fmla="val 8421"/>
             </a:avLst>
           </a:prstGeom>
           <a:solidFill>
@@ -4107,13 +4266,13 @@
       </p:sp>
       <p:sp>
         <p:nvSpPr>
-          <p:cNvPr id="11" name="Text 9"/>
-          <p:cNvSpPr txBox="1"/>
-          <p:nvPr/>
-        </p:nvSpPr>
-        <p:spPr>
-          <a:xfrm>
-            <a:off x="868680" y="3941064"/>
+          <p:cNvPr id="12" name="Text 10"/>
+          <p:cNvSpPr txBox="1"/>
+          <p:nvPr/>
+        </p:nvSpPr>
+        <p:spPr>
+          <a:xfrm>
+            <a:off x="868680" y="4160520"/>
             <a:ext cx="3657600" cy="365760"/>
           </a:xfrm>
           <a:prstGeom prst="rect">
@@ -4146,14 +4305,14 @@
       </p:sp>
       <p:sp>
         <p:nvSpPr>
-          <p:cNvPr id="12" name="Text 10"/>
-          <p:cNvSpPr txBox="1"/>
-          <p:nvPr/>
-        </p:nvSpPr>
-        <p:spPr>
-          <a:xfrm>
-            <a:off x="868680" y="4288536"/>
-            <a:ext cx="10424160" cy="411480"/>
+          <p:cNvPr id="13" name="Text 11"/>
+          <p:cNvSpPr txBox="1"/>
+          <p:nvPr/>
+        </p:nvSpPr>
+        <p:spPr>
+          <a:xfrm>
+            <a:off x="868680" y="4489704"/>
+            <a:ext cx="10424160" cy="384048"/>
           </a:xfrm>
           <a:prstGeom prst="rect">
             <a:avLst/>
@@ -4185,18 +4344,18 @@
       </p:sp>
       <p:sp>
         <p:nvSpPr>
-          <p:cNvPr id="13" name="Shape 11"/>
+          <p:cNvPr id="14" name="Shape 12"/>
           <p:cNvSpPr/>
           <p:nvPr/>
         </p:nvSpPr>
         <p:spPr>
           <a:xfrm>
-            <a:off x="548640" y="4946904"/>
-            <a:ext cx="11064240" cy="960120"/>
+            <a:off x="548640" y="5074920"/>
+            <a:ext cx="11064240" cy="868680"/>
           </a:xfrm>
           <a:prstGeom prst="roundRect">
             <a:avLst>
-              <a:gd name="adj" fmla="val 7619"/>
+              <a:gd name="adj" fmla="val 8421"/>
             </a:avLst>
           </a:prstGeom>
           <a:solidFill>
@@ -4212,13 +4371,13 @@
       </p:sp>
       <p:sp>
         <p:nvSpPr>
-          <p:cNvPr id="14" name="Text 12"/>
-          <p:cNvSpPr txBox="1"/>
-          <p:nvPr/>
-        </p:nvSpPr>
-        <p:spPr>
-          <a:xfrm>
-            <a:off x="868680" y="5056632"/>
+          <p:cNvPr id="15" name="Text 13"/>
+          <p:cNvSpPr txBox="1"/>
+          <p:nvPr/>
+        </p:nvSpPr>
+        <p:spPr>
+          <a:xfrm>
+            <a:off x="868680" y="5166360"/>
             <a:ext cx="3657600" cy="365760"/>
           </a:xfrm>
           <a:prstGeom prst="rect">
@@ -4251,14 +4410,14 @@
       </p:sp>
       <p:sp>
         <p:nvSpPr>
-          <p:cNvPr id="15" name="Text 13"/>
-          <p:cNvSpPr txBox="1"/>
-          <p:nvPr/>
-        </p:nvSpPr>
-        <p:spPr>
-          <a:xfrm>
-            <a:off x="868680" y="5404104"/>
-            <a:ext cx="10424160" cy="411480"/>
+          <p:cNvPr id="16" name="Text 14"/>
+          <p:cNvSpPr txBox="1"/>
+          <p:nvPr/>
+        </p:nvSpPr>
+        <p:spPr>
+          <a:xfrm>
+            <a:off x="868680" y="5495544"/>
+            <a:ext cx="10424160" cy="384048"/>
           </a:xfrm>
           <a:prstGeom prst="rect">
             <a:avLst/>
@@ -4290,7 +4449,7 @@
       </p:sp>
       <p:sp>
         <p:nvSpPr>
-          <p:cNvPr id="16" name="Text 14"/>
+          <p:cNvPr id="17" name="Text 15"/>
           <p:cNvSpPr txBox="1"/>
           <p:nvPr/>
         </p:nvSpPr>

</xml_diff>